<commit_message>
Finalize Assignment 16 submission package
</commit_message>
<xml_diff>
--- a/presentation/Group16_AI_Text_Detection_Robustness.pptx
+++ b/presentation/Group16_AI_Text_Detection_Robustness.pptx
@@ -11342,27 +11342,14 @@
           </a:bodyPr>
           <a:lstStyle/>
           <a:p>
-            <a:pPr indent="0" lvl="0" marL="0" marR="0" rtl="0" algn="ctr">
-              <a:spcBef>
-                <a:spcPts val="0"/>
-              </a:spcBef>
-              <a:spcAft>
-                <a:spcPts val="0"/>
-              </a:spcAft>
-              <a:buNone/>
-            </a:pPr>
             <a:r>
-              <a:t/>
+              <a:rPr sz="1700">
+                <a:solidFill>
+                  <a:srgbClr val="46505F"/>
+                </a:solidFill>
+              </a:rPr>
+              <a:t>Assignment 16 | 11 October 2026</a:t>
             </a:r>
-            <a:endParaRPr b="0" i="0" sz="1800" u="none" cap="none" strike="noStrike">
-              <a:solidFill>
-                <a:schemeClr val="dk1"/>
-              </a:solidFill>
-              <a:latin typeface="Calibri"/>
-              <a:ea typeface="Calibri"/>
-              <a:cs typeface="Calibri"/>
-              <a:sym typeface="Calibri"/>
-            </a:endParaRPr>
           </a:p>
         </p:txBody>
       </p:sp>
@@ -11391,48 +11378,10 @@
           </a:bodyPr>
           <a:lstStyle/>
           <a:p>
-            <a:pPr indent="0" lvl="0" marL="0" marR="0" rtl="0" algn="l">
-              <a:spcBef>
-                <a:spcPts val="0"/>
-              </a:spcBef>
-              <a:spcAft>
-                <a:spcPts val="0"/>
-              </a:spcAft>
-              <a:buNone/>
-            </a:pPr>
             <a:r>
-              <a:rPr b="1" i="0" lang="en-US" sz="1300" u="none" cap="none" strike="noStrike">
-                <a:solidFill>
-                  <a:srgbClr val="A0D2DC"/>
-                </a:solidFill>
-                <a:latin typeface="Arial"/>
-                <a:ea typeface="Arial"/>
-                <a:cs typeface="Arial"/>
-                <a:sym typeface="Arial"/>
-              </a:rPr>
-              <a:t>AI26501 • M</a:t>
+              <a:rPr sz="1300"/>
+              <a:t>AI26501 • MODERN AI ASSIGNMENTS • GROUP 16</a:t>
             </a:r>
-            <a:r>
-              <a:rPr b="1" lang="en-US" sz="1300">
-                <a:solidFill>
-                  <a:srgbClr val="A0D2DC"/>
-                </a:solidFill>
-              </a:rPr>
-              <a:t>AI</a:t>
-            </a:r>
-            <a:r>
-              <a:rPr b="1" i="0" lang="en-US" sz="1300" u="none" cap="none" strike="noStrike">
-                <a:solidFill>
-                  <a:srgbClr val="A0D2DC"/>
-                </a:solidFill>
-                <a:latin typeface="Arial"/>
-                <a:ea typeface="Arial"/>
-                <a:cs typeface="Arial"/>
-                <a:sym typeface="Arial"/>
-              </a:rPr>
-              <a:t>ASSIGNMENTS </a:t>
-            </a:r>
-            <a:endParaRPr/>
           </a:p>
         </p:txBody>
       </p:sp>
@@ -11535,19 +11484,14 @@
           </a:bodyPr>
           <a:lstStyle/>
           <a:p>
-            <a:pPr indent="0" lvl="0" marL="0" marR="0" rtl="0" algn="l">
-              <a:spcBef>
-                <a:spcPts val="0"/>
-              </a:spcBef>
-              <a:spcAft>
-                <a:spcPts val="0"/>
-              </a:spcAft>
-              <a:buNone/>
-            </a:pPr>
             <a:r>
-              <a:t/>
+              <a:rPr sz="1200">
+                <a:solidFill>
+                  <a:srgbClr val="46505F"/>
+                </a:solidFill>
+              </a:rPr>
+              <a:t>HC3 • TF–IDF + LinearSVC • Controlled robustness evaluation</a:t>
             </a:r>
-            <a:endParaRPr/>
           </a:p>
         </p:txBody>
       </p:sp>
@@ -11790,97 +11734,49 @@
           </a:bodyPr>
           <a:lstStyle/>
           <a:p>
-            <a:pPr indent="0" lvl="0" marL="0" marR="0" rtl="0" algn="l">
-              <a:spcBef>
-                <a:spcPts val="0"/>
-              </a:spcBef>
-              <a:spcAft>
-                <a:spcPts val="0"/>
-              </a:spcAft>
-              <a:buNone/>
+            <a:pPr>
+              <a:spcAft>
+                <a:spcPts val="800"/>
+              </a:spcAft>
             </a:pPr>
             <a:r>
-              <a:rPr b="0" lang="en-US" sz="1500" u="none" cap="none" strike="noStrike">
+              <a:rPr sz="1600">
                 <a:solidFill>
-                  <a:srgbClr val="28303C"/>
+                  <a:srgbClr val="2D3746"/>
                 </a:solidFill>
-                <a:highlight>
-                  <a:schemeClr val="lt1"/>
-                </a:highlight>
-                <a:latin typeface="Arial"/>
-                <a:ea typeface="Arial"/>
-                <a:cs typeface="Arial"/>
-                <a:sym typeface="Arial"/>
               </a:rPr>
-              <a:t>Original AI recall was 98.00%; the tested surface edits did not measurably change performance.</a:t>
+              <a:t>In this HC3 sample, original AI recall was 98.00%; the tested surface edits did not measurably change performance.</a:t>
             </a:r>
-            <a:endParaRPr>
-              <a:highlight>
-                <a:schemeClr val="lt1"/>
-              </a:highlight>
-            </a:endParaRPr>
           </a:p>
           <a:p>
-            <a:pPr indent="0" lvl="0" marL="0" marR="0" rtl="0" algn="l">
-              <a:spcBef>
-                <a:spcPts val="1000"/>
-              </a:spcBef>
-              <a:spcAft>
-                <a:spcPts val="0"/>
-              </a:spcAft>
-              <a:buNone/>
+            <a:pPr>
+              <a:spcAft>
+                <a:spcPts val="800"/>
+              </a:spcAft>
             </a:pPr>
             <a:r>
-              <a:rPr b="0" lang="en-US" sz="1500" u="none" cap="none" strike="noStrike">
+              <a:rPr sz="1600">
                 <a:solidFill>
-                  <a:srgbClr val="28303C"/>
+                  <a:srgbClr val="2D3746"/>
                 </a:solidFill>
-                <a:highlight>
-                  <a:schemeClr val="lt1"/>
-                </a:highlight>
-                <a:latin typeface="Arial"/>
-                <a:ea typeface="Arial"/>
-                <a:cs typeface="Arial"/>
-                <a:sym typeface="Arial"/>
               </a:rPr>
-              <a:t>Semantic paraphrases reduced recall to 79.67% (−18.33 pp); false negatives rose from 6 to 61.</a:t>
+              <a:t>Semantic paraphraser outputs reduced recall to 79.67% (−18.33 pp); false negatives rose from 6 to 61.</a:t>
             </a:r>
-            <a:endParaRPr>
-              <a:highlight>
-                <a:schemeClr val="lt1"/>
-              </a:highlight>
-            </a:endParaRPr>
           </a:p>
           <a:p>
-            <a:pPr indent="0" lvl="0" marL="0" marR="0" rtl="0" algn="l">
-              <a:spcBef>
-                <a:spcPts val="1000"/>
-              </a:spcBef>
-              <a:spcAft>
-                <a:spcPts val="0"/>
-              </a:spcAft>
-              <a:buNone/>
+            <a:pPr>
+              <a:spcAft>
+                <a:spcPts val="800"/>
+              </a:spcAft>
             </a:pPr>
             <a:r>
-              <a:rPr b="0" lang="en-US" sz="1500" u="none" cap="none" strike="noStrike">
+              <a:rPr sz="1600">
                 <a:solidFill>
-                  <a:srgbClr val="28303C"/>
+                  <a:srgbClr val="2D3746"/>
                 </a:solidFill>
-                <a:highlight>
-                  <a:schemeClr val="lt1"/>
-                </a:highlight>
-                <a:latin typeface="Arial"/>
-                <a:ea typeface="Arial"/>
-                <a:cs typeface="Arial"/>
-                <a:sym typeface="Arial"/>
               </a:rPr>
-              <a:t>Strong performance on untouched text did not guarantee robustness to rewriting.</a:t>
+              <a:t>This is evidence about this detector, dataset, and paraphrasing process—not all AI detectors or all meaning-preserving rewrites.</a:t>
             </a:r>
-            <a:endParaRPr>
-              <a:highlight>
-                <a:schemeClr val="lt1"/>
-              </a:highlight>
-            </a:endParaRPr>
           </a:p>
         </p:txBody>
       </p:sp>
@@ -16242,33 +16138,6 @@
           </a:p>
         </p:txBody>
       </p:sp>
-      <p:pic>
-        <p:nvPicPr>
-          <p:cNvPr descr="metrics_comparison.png" id="181" name="Google Shape;181;p6"/>
-          <p:cNvPicPr preferRelativeResize="0"/>
-          <p:nvPr/>
-        </p:nvPicPr>
-        <p:blipFill rotWithShape="1">
-          <a:blip r:embed="rId3">
-            <a:alphaModFix/>
-          </a:blip>
-          <a:srcRect b="0" l="0" r="0" t="0"/>
-          <a:stretch/>
-        </p:blipFill>
-        <p:spPr>
-          <a:xfrm>
-            <a:off x="411480" y="1234440"/>
-            <a:ext cx="7406640" cy="3847732"/>
-          </a:xfrm>
-          <a:prstGeom prst="rect">
-            <a:avLst/>
-          </a:prstGeom>
-          <a:noFill/>
-          <a:ln>
-            <a:noFill/>
-          </a:ln>
-        </p:spPr>
-      </p:pic>
       <p:graphicFrame>
         <p:nvGraphicFramePr>
           <p:cNvPr id="182" name="Google Shape;182;p6"/>
@@ -16925,28 +16794,24 @@
           </a:bodyPr>
           <a:lstStyle/>
           <a:p>
-            <a:pPr indent="0" lvl="0" marL="0" marR="0" rtl="0" algn="l">
-              <a:spcBef>
-                <a:spcPts val="0"/>
-              </a:spcBef>
-              <a:spcAft>
-                <a:spcPts val="0"/>
-              </a:spcAft>
-              <a:buNone/>
-            </a:pPr>
             <a:r>
-              <a:rPr b="0" i="0" lang="en-US" sz="1200" u="none" cap="none" strike="noStrike">
+              <a:rPr sz="1500">
                 <a:solidFill>
-                  <a:srgbClr val="28303C"/>
+                  <a:srgbClr val="323C4B"/>
                 </a:solidFill>
-                <a:latin typeface="Arial"/>
-                <a:ea typeface="Arial"/>
-                <a:cs typeface="Arial"/>
-                <a:sym typeface="Arial"/>
               </a:rPr>
-              <a:t>False positive rate stayed at 0.33%.</a:t>
+              <a:t>FPR: 0.33% in all three conditions.</a:t>
             </a:r>
-            <a:endParaRPr/>
+          </a:p>
+          <a:p>
+            <a:r>
+              <a:rPr sz="1500">
+                <a:solidFill>
+                  <a:srgbClr val="323C4B"/>
+                </a:solidFill>
+              </a:rPr>
+              <a:t>Human false positives: 1/300 per condition.</a:t>
+            </a:r>
           </a:p>
         </p:txBody>
       </p:sp>
@@ -17050,6 +16915,30 @@
           </a:p>
         </p:txBody>
       </p:sp>
+      <p:pic>
+        <p:nvPicPr>
+          <p:cNvPr id="188" name="Picture 187" descr="slide6_metrics_chart.png"/>
+          <p:cNvPicPr>
+            <a:picLocks noChangeAspect="1"/>
+          </p:cNvPicPr>
+          <p:nvPr/>
+        </p:nvPicPr>
+        <p:blipFill>
+          <a:blip r:embed="rId4"/>
+          <a:stretch>
+            <a:fillRect/>
+          </a:stretch>
+        </p:blipFill>
+        <p:spPr>
+          <a:xfrm>
+            <a:off x="411480" y="1234440"/>
+            <a:ext cx="7406640" cy="3847732"/>
+          </a:xfrm>
+          <a:prstGeom prst="rect">
+            <a:avLst/>
+          </a:prstGeom>
+        </p:spPr>
+      </p:pic>
     </p:spTree>
   </p:cSld>
   <p:clrMapOvr>
@@ -17906,124 +17795,94 @@
           </a:bodyPr>
           <a:lstStyle/>
           <a:p>
-            <a:pPr indent="0" lvl="0" marL="0" marR="0" rtl="0" algn="l">
-              <a:spcBef>
-                <a:spcPts val="0"/>
-              </a:spcBef>
-              <a:spcAft>
-                <a:spcPts val="0"/>
-              </a:spcAft>
-              <a:buNone/>
+            <a:pPr>
+              <a:spcAft>
+                <a:spcPts val="800"/>
+              </a:spcAft>
             </a:pPr>
             <a:r>
-              <a:rPr b="0" i="0" lang="en-US" sz="1400" u="none" cap="none" strike="noStrike">
+              <a:rPr sz="1500">
                 <a:solidFill>
-                  <a:srgbClr val="28303C"/>
+                  <a:srgbClr val="2D3746"/>
                 </a:solidFill>
-                <a:latin typeface="Arial"/>
-                <a:ea typeface="Arial"/>
-                <a:cs typeface="Arial"/>
-                <a:sym typeface="Arial"/>
               </a:rPr>
-              <a:t>Finance recall: 100% → 78.95%.</a:t>
+              <a:t>AI recall (AI passages per source):</a:t>
             </a:r>
-            <a:endParaRPr/>
           </a:p>
           <a:p>
-            <a:pPr indent="0" lvl="0" marL="0" marR="0" rtl="0" algn="l">
-              <a:spcBef>
-                <a:spcPts val="1000"/>
-              </a:spcBef>
-              <a:spcAft>
-                <a:spcPts val="0"/>
-              </a:spcAft>
-              <a:buNone/>
+            <a:pPr>
+              <a:spcAft>
+                <a:spcPts val="800"/>
+              </a:spcAft>
             </a:pPr>
             <a:r>
-              <a:rPr b="0" i="0" lang="en-US" sz="1400" u="none" cap="none" strike="noStrike">
+              <a:rPr sz="1500">
                 <a:solidFill>
-                  <a:srgbClr val="28303C"/>
+                  <a:srgbClr val="2D3746"/>
                 </a:solidFill>
-                <a:latin typeface="Arial"/>
-                <a:ea typeface="Arial"/>
-                <a:cs typeface="Arial"/>
-                <a:sym typeface="Arial"/>
               </a:rPr>
-              <a:t>Reddit ELI5: 97.75% → 77.93%.</a:t>
+              <a:t>Finance (n=38): 100% → 78.95%.</a:t>
             </a:r>
-            <a:endParaRPr/>
           </a:p>
           <a:p>
-            <a:pPr indent="0" lvl="0" marL="0" marR="0" rtl="0" algn="l">
-              <a:spcBef>
-                <a:spcPts val="1000"/>
-              </a:spcBef>
-              <a:spcAft>
-                <a:spcPts val="0"/>
-              </a:spcAft>
-              <a:buNone/>
+            <a:pPr>
+              <a:spcAft>
+                <a:spcPts val="800"/>
+              </a:spcAft>
             </a:pPr>
             <a:r>
-              <a:rPr b="0" i="0" lang="en-US" sz="1400" u="none" cap="none" strike="noStrike">
+              <a:rPr sz="1500">
                 <a:solidFill>
-                  <a:srgbClr val="28303C"/>
+                  <a:srgbClr val="2D3746"/>
                 </a:solidFill>
-                <a:latin typeface="Arial"/>
-                <a:ea typeface="Arial"/>
-                <a:cs typeface="Arial"/>
-                <a:sym typeface="Arial"/>
               </a:rPr>
-              <a:t>Open QA: 95.45% → 86.36%.</a:t>
+              <a:t>Reddit ELI5 (n=222): 97.75% → 77.93%.</a:t>
             </a:r>
-            <a:endParaRPr/>
           </a:p>
           <a:p>
-            <a:pPr indent="0" lvl="0" marL="0" marR="0" rtl="0" algn="l">
-              <a:spcBef>
-                <a:spcPts val="1000"/>
-              </a:spcBef>
-              <a:spcAft>
-                <a:spcPts val="0"/>
-              </a:spcAft>
-              <a:buNone/>
+            <a:pPr>
+              <a:spcAft>
+                <a:spcPts val="800"/>
+              </a:spcAft>
             </a:pPr>
             <a:r>
-              <a:rPr b="0" i="0" lang="en-US" sz="1400" u="none" cap="none" strike="noStrike">
+              <a:rPr sz="1500">
                 <a:solidFill>
-                  <a:srgbClr val="28303C"/>
+                  <a:srgbClr val="2D3746"/>
                 </a:solidFill>
-                <a:latin typeface="Arial"/>
-                <a:ea typeface="Arial"/>
-                <a:cs typeface="Arial"/>
-                <a:sym typeface="Arial"/>
               </a:rPr>
-              <a:t>Medicine unchanged in this sample.</a:t>
+              <a:t>Open QA (n=22): 95.45% → 86.36%.</a:t>
             </a:r>
-            <a:endParaRPr/>
           </a:p>
           <a:p>
-            <a:pPr indent="0" lvl="0" marL="0" marR="0" rtl="0" algn="l">
-              <a:spcBef>
-                <a:spcPts val="1000"/>
-              </a:spcBef>
-              <a:spcAft>
-                <a:spcPts val="0"/>
-              </a:spcAft>
-              <a:buNone/>
+            <a:pPr>
+              <a:spcAft>
+                <a:spcPts val="800"/>
+              </a:spcAft>
             </a:pPr>
             <a:r>
-              <a:rPr b="0" i="0" lang="en-US" sz="1400" u="none" cap="none" strike="noStrike">
+              <a:rPr sz="1500">
                 <a:solidFill>
-                  <a:srgbClr val="28303C"/>
+                  <a:srgbClr val="2D3746"/>
                 </a:solidFill>
-                <a:latin typeface="Arial"/>
-                <a:ea typeface="Arial"/>
-                <a:cs typeface="Arial"/>
-                <a:sym typeface="Arial"/>
               </a:rPr>
-              <a:t>Wiki CSAI: 66.67% after paraphrasing, but only 3 AI passages.</a:t>
+              <a:t>Medicine (n=15): unchanged in this sample.</a:t>
             </a:r>
-            <a:endParaRPr/>
+          </a:p>
+          <a:p>
+            <a:pPr>
+              <a:spcAft>
+                <a:spcPts val="800"/>
+              </a:spcAft>
+            </a:pPr>
+            <a:r>
+              <a:rPr sz="1500">
+                <a:solidFill>
+                  <a:srgbClr val="2D3746"/>
+                </a:solidFill>
+              </a:rPr>
+              <a:t>Wiki CSAI (n=3): 66.67% after paraphrasing.</a:t>
+            </a:r>
           </a:p>
         </p:txBody>
       </p:sp>

</xml_diff>